<commit_message>
Correct LinkedIn/Credly wording on slides 8 and 20 of AI-901 orientation deck
Co-Authored-By: Claude Opus 5.5 <noreply@anthropic.com>
Claude-Session: https://claude.ai/code/session_01KzpMbwa4XL636N9TvhC8vz
</commit_message>
<xml_diff>
--- a/AI901-1. 오리엔테이션과정 소개 및 사전 진단 v3.pptx
+++ b/AI901-1. 오리엔테이션과정 소개 및 사전 진단 v3.pptx
@@ -22759,7 +22759,7 @@
                 <a:ea typeface="Arial" pitchFamily="34" charset="-122"/>
                 <a:cs typeface="Arial" pitchFamily="34" charset="-120"/>
               </a:rPr>
-              <a:t>Credly 자동 발급 · LinkedIn 연동</a:t>
+              <a:t>Microsoft Learn 공식 인증 · LinkedIn 공유</a:t>
             </a:r>
             <a:endParaRPr lang="en-US" sz="1200" dirty="0"/>
           </a:p>
@@ -48911,7 +48911,7 @@
                 <a:ea typeface="Arial" pitchFamily="34" charset="-122"/>
                 <a:cs typeface="Arial" pitchFamily="34" charset="-120"/>
               </a:rPr>
-              <a:t>• LinkedIn 공식 배지 자동 노출</a:t>
+              <a:t>• LinkedIn에 공식 자격증 공유 가능</a:t>
             </a:r>
             <a:endParaRPr lang="en-US" sz="1100" dirty="0"/>
           </a:p>

</xml_diff>

<commit_message>
Replace badge wording on slides 1, 20 and 24 of AI-901 orientation deck
Co-Authored-By: Claude Opus 5.5 <noreply@anthropic.com>
Claude-Session: https://claude.ai/code/session_01KzpMbwa4XL636N9TvhC8vz
</commit_message>
<xml_diff>
--- a/AI901-1. 오리엔테이션과정 소개 및 사전 진단 v3.pptx
+++ b/AI901-1. 오리엔테이션과정 소개 및 사전 진단 v3.pptx
@@ -5943,7 +5943,7 @@
                 <a:ea typeface="Arial" pitchFamily="34" charset="-122"/>
                 <a:cs typeface="Arial" pitchFamily="34" charset="-120"/>
               </a:rPr>
-              <a:t>Microsoft 공식 디지털 배지</a:t>
+              <a:t>Microsoft 공식 자격증 취득</a:t>
             </a:r>
             <a:endParaRPr lang="en-US" sz="1300" dirty="0"/>
           </a:p>
@@ -22720,7 +22720,7 @@
                 <a:ea typeface="Arial" pitchFamily="34" charset="-122"/>
                 <a:cs typeface="Arial" pitchFamily="34" charset="-120"/>
               </a:rPr>
-              <a:t>디지털 배지</a:t>
+              <a:t>자격 인증</a:t>
             </a:r>
             <a:endParaRPr lang="en-US" sz="1200" dirty="0"/>
           </a:p>
@@ -28278,7 +28278,7 @@
                 <a:ea typeface="Arial" pitchFamily="34" charset="-122"/>
                 <a:cs typeface="Arial" pitchFamily="34" charset="-120"/>
               </a:rPr>
-              <a:t>배지 자동 발급</a:t>
+              <a:t>Learn 프로필 등록</a:t>
             </a:r>
             <a:endParaRPr lang="en-US" sz="1000" dirty="0"/>
           </a:p>

</xml_diff>